<commit_message>
Personalize demo presentation with student details and SCAD logo
</commit_message>
<xml_diff>
--- a/presentation/demo-ready/Nellai_Green_Civic_Demo_Ready.pptx
+++ b/presentation/demo-ready/Nellai_Green_Civic_Demo_Ready.pptx
@@ -524,7 +524,7 @@
           <a:lstStyle/>
           <a:p>
             <a:r>
-              <a:t>Introduce yourself and your college. This localhost prototype manages complaints and sends authority alerts. Gmail accepted test NGC-063524AD on 7 October 2026; inbox arrival is checked separately. The ZIP supports a Python 3.12 setup on Windows, Linux and macOS. AI classification is a future extension.</a:t>
+              <a:t>Good morning. I am Santhiya M, register number 952825405014, a final-year M.E. Computer Science and Engineering student at SCAD College of Engineering &amp; Technology. My project is Nellai Green &amp; Civic. This localhost prototype manages complaints and sends authority alerts. Gmail accepted test NGC-063524AD on 7 October 2026; inbox arrival is checked separately. The ZIP supports a Python 3.12 setup on Windows, Linux and macOS. AI classification is a future extension.</a:t>
             </a:r>
           </a:p>
         </p:txBody>
@@ -5233,7 +5233,7 @@
               </a:defRPr>
             </a:pPr>
             <a:r>
-              <a:t>ME PROJECT  /  LOCALHOST DEMONSTRATION  /  EDITABLE PRESENTATION</a:t>
+              <a:t>SANTHIYA M  /  M.E. CSE, FINAL YEAR  /  SCAD COLLEGE OF ENGINEERING &amp; TECHNOLOGY</a:t>
             </a:r>
           </a:p>
         </p:txBody>
@@ -5518,8 +5518,8 @@
         </p:nvSpPr>
         <p:spPr>
           <a:xfrm>
-            <a:off x="640080" y="4480560"/>
-            <a:ext cx="10698480" cy="1554480"/>
+            <a:off x="640080" y="4407408"/>
+            <a:ext cx="6217920" cy="274320"/>
           </a:xfrm>
           <a:prstGeom prst="rect">
             <a:avLst/>
@@ -5536,6 +5536,84 @@
               <a:spcAft>
                 <a:spcPts val="700"/>
               </a:spcAft>
+              <a:defRPr sz="1200" b="1">
+                <a:solidFill>
+                  <a:srgbClr val="B7CB92"/>
+                </a:solidFill>
+                <a:latin typeface="Aptos"/>
+              </a:defRPr>
+            </a:pPr>
+            <a:r>
+              <a:t>PRESENTED BY</a:t>
+            </a:r>
+          </a:p>
+        </p:txBody>
+      </p:sp>
+      <p:sp>
+        <p:nvSpPr>
+          <p:cNvPr id="13" name="TextBox 12"/>
+          <p:cNvSpPr txBox="1"/>
+          <p:nvPr/>
+        </p:nvSpPr>
+        <p:spPr>
+          <a:xfrm>
+            <a:off x="640080" y="4773168"/>
+            <a:ext cx="6217920" cy="502920"/>
+          </a:xfrm>
+          <a:prstGeom prst="rect">
+            <a:avLst/>
+          </a:prstGeom>
+          <a:noFill/>
+        </p:spPr>
+        <p:txBody>
+          <a:bodyPr wrap="square" lIns="9144" rIns="9144" tIns="0" bIns="0">
+            <a:spAutoFit/>
+          </a:bodyPr>
+          <a:lstStyle/>
+          <a:p>
+            <a:pPr>
+              <a:spcAft>
+                <a:spcPts val="700"/>
+              </a:spcAft>
+              <a:defRPr sz="2700" b="1">
+                <a:solidFill>
+                  <a:srgbClr val="FFFFFF"/>
+                </a:solidFill>
+                <a:latin typeface="Aptos"/>
+              </a:defRPr>
+            </a:pPr>
+            <a:r>
+              <a:t>Santhiya M</a:t>
+            </a:r>
+          </a:p>
+        </p:txBody>
+      </p:sp>
+      <p:sp>
+        <p:nvSpPr>
+          <p:cNvPr id="14" name="TextBox 13"/>
+          <p:cNvSpPr txBox="1"/>
+          <p:nvPr/>
+        </p:nvSpPr>
+        <p:spPr>
+          <a:xfrm>
+            <a:off x="640080" y="5422392"/>
+            <a:ext cx="6217920" cy="320040"/>
+          </a:xfrm>
+          <a:prstGeom prst="rect">
+            <a:avLst/>
+          </a:prstGeom>
+          <a:noFill/>
+        </p:spPr>
+        <p:txBody>
+          <a:bodyPr wrap="square" lIns="9144" rIns="9144" tIns="0" bIns="0">
+            <a:spAutoFit/>
+          </a:bodyPr>
+          <a:lstStyle/>
+          <a:p>
+            <a:pPr>
+              <a:spcAft>
+                <a:spcPts val="700"/>
+              </a:spcAft>
               <a:defRPr sz="1700" b="0">
                 <a:solidFill>
                   <a:srgbClr val="DCE8CF"/>
@@ -5544,9 +5622,32 @@
               </a:defRPr>
             </a:pPr>
             <a:r>
-              <a:t>M.E. Computer Science &amp; Engineering</a:t>
-            </a:r>
-          </a:p>
+              <a:t>Register No.: 952825405014</a:t>
+            </a:r>
+          </a:p>
+        </p:txBody>
+      </p:sp>
+      <p:sp>
+        <p:nvSpPr>
+          <p:cNvPr id="15" name="TextBox 14"/>
+          <p:cNvSpPr txBox="1"/>
+          <p:nvPr/>
+        </p:nvSpPr>
+        <p:spPr>
+          <a:xfrm>
+            <a:off x="640080" y="5815584"/>
+            <a:ext cx="6217920" cy="329184"/>
+          </a:xfrm>
+          <a:prstGeom prst="rect">
+            <a:avLst/>
+          </a:prstGeom>
+          <a:noFill/>
+        </p:spPr>
+        <p:txBody>
+          <a:bodyPr wrap="square" lIns="9144" rIns="9144" tIns="0" bIns="0">
+            <a:spAutoFit/>
+          </a:bodyPr>
+          <a:lstStyle/>
           <a:p>
             <a:pPr>
               <a:spcAft>
@@ -5560,15 +5661,107 @@
               </a:defRPr>
             </a:pPr>
             <a:r>
-              <a:t>Working localhost demonstration</a:t>
-            </a:r>
-          </a:p>
-          <a:p>
-            <a:pPr>
-              <a:spcAft>
-                <a:spcPts val="700"/>
-              </a:spcAft>
-              <a:defRPr sz="1700" b="0">
+              <a:t>M.E. CSE — Final Year</a:t>
+            </a:r>
+          </a:p>
+        </p:txBody>
+      </p:sp>
+      <p:sp>
+        <p:nvSpPr>
+          <p:cNvPr id="16" name="Rounded Rectangle 15"/>
+          <p:cNvSpPr/>
+          <p:nvPr/>
+        </p:nvSpPr>
+        <p:spPr>
+          <a:xfrm>
+            <a:off x="7406640" y="4535424"/>
+            <a:ext cx="4114800" cy="1280160"/>
+          </a:xfrm>
+          <a:prstGeom prst="roundRect">
+            <a:avLst>
+              <a:gd name="adj" fmla="val 12000"/>
+            </a:avLst>
+          </a:prstGeom>
+          <a:solidFill>
+            <a:srgbClr val="FFFFFF"/>
+          </a:solidFill>
+          <a:ln>
+            <a:noFill/>
+          </a:ln>
+        </p:spPr>
+        <p:style>
+          <a:lnRef idx="1">
+            <a:schemeClr val="accent1"/>
+          </a:lnRef>
+          <a:fillRef idx="3">
+            <a:schemeClr val="accent1"/>
+          </a:fillRef>
+          <a:effectRef idx="2">
+            <a:schemeClr val="accent1"/>
+          </a:effectRef>
+          <a:fontRef idx="minor">
+            <a:schemeClr val="lt1"/>
+          </a:fontRef>
+        </p:style>
+        <p:txBody>
+          <a:bodyPr rtlCol="0" anchor="ctr"/>
+          <a:lstStyle/>
+          <a:p>
+            <a:pPr algn="ctr"/>
+          </a:p>
+        </p:txBody>
+      </p:sp>
+      <p:pic>
+        <p:nvPicPr>
+          <p:cNvPr id="17" name="Picture 16" descr="scad-college-logo.png"/>
+          <p:cNvPicPr>
+            <a:picLocks noChangeAspect="1"/>
+          </p:cNvPicPr>
+          <p:nvPr/>
+        </p:nvPicPr>
+        <p:blipFill>
+          <a:blip r:embed="rId2"/>
+          <a:stretch>
+            <a:fillRect/>
+          </a:stretch>
+        </p:blipFill>
+        <p:spPr>
+          <a:xfrm>
+            <a:off x="7571231" y="4677156"/>
+            <a:ext cx="3785615" cy="991831"/>
+          </a:xfrm>
+          <a:prstGeom prst="rect">
+            <a:avLst/>
+          </a:prstGeom>
+        </p:spPr>
+      </p:pic>
+      <p:sp>
+        <p:nvSpPr>
+          <p:cNvPr id="18" name="TextBox 17"/>
+          <p:cNvSpPr txBox="1"/>
+          <p:nvPr/>
+        </p:nvSpPr>
+        <p:spPr>
+          <a:xfrm>
+            <a:off x="7360920" y="5952744"/>
+            <a:ext cx="4206240" cy="365760"/>
+          </a:xfrm>
+          <a:prstGeom prst="rect">
+            <a:avLst/>
+          </a:prstGeom>
+          <a:noFill/>
+        </p:spPr>
+        <p:txBody>
+          <a:bodyPr wrap="square" lIns="9144" rIns="9144" tIns="0" bIns="0">
+            <a:spAutoFit/>
+          </a:bodyPr>
+          <a:lstStyle/>
+          <a:p>
+            <a:pPr algn="ctr">
+              <a:spcAft>
+                <a:spcPts val="700"/>
+              </a:spcAft>
+              <a:defRPr sz="1200" b="0">
                 <a:solidFill>
                   <a:srgbClr val="DCE8CF"/>
                 </a:solidFill>
@@ -5576,23 +5769,7 @@
               </a:defRPr>
             </a:pPr>
             <a:r>
-              <a:t>Tirunelveli / Nellai</a:t>
-            </a:r>
-          </a:p>
-          <a:p>
-            <a:pPr>
-              <a:spcAft>
-                <a:spcPts val="700"/>
-              </a:spcAft>
-              <a:defRPr sz="1700" b="0">
-                <a:solidFill>
-                  <a:srgbClr val="DCE8CF"/>
-                </a:solidFill>
-                <a:latin typeface="Aptos"/>
-              </a:defRPr>
-            </a:pPr>
-            <a:r>
-              <a:t>Web application, email outbox and community modules</a:t>
+              <a:t>SCAD College of Engineering &amp; Technology</a:t>
             </a:r>
           </a:p>
         </p:txBody>
@@ -5817,7 +5994,7 @@
               </a:defRPr>
             </a:pPr>
             <a:r>
-              <a:t>ME PROJECT  /  LOCALHOST DEMONSTRATION  /  EDITABLE PRESENTATION</a:t>
+              <a:t>SANTHIYA M  /  M.E. CSE, FINAL YEAR  /  SCAD COLLEGE OF ENGINEERING &amp; TECHNOLOGY</a:t>
             </a:r>
           </a:p>
         </p:txBody>
@@ -6407,7 +6584,7 @@
               </a:defRPr>
             </a:pPr>
             <a:r>
-              <a:t>ME PROJECT  /  LOCALHOST DEMONSTRATION  /  EDITABLE PRESENTATION</a:t>
+              <a:t>SANTHIYA M  /  M.E. CSE, FINAL YEAR  /  SCAD COLLEGE OF ENGINEERING &amp; TECHNOLOGY</a:t>
             </a:r>
           </a:p>
         </p:txBody>
@@ -7235,7 +7412,7 @@
               </a:defRPr>
             </a:pPr>
             <a:r>
-              <a:t>ME PROJECT  /  LOCALHOST DEMONSTRATION  /  EDITABLE PRESENTATION</a:t>
+              <a:t>SANTHIYA M  /  M.E. CSE, FINAL YEAR  /  SCAD COLLEGE OF ENGINEERING &amp; TECHNOLOGY</a:t>
             </a:r>
           </a:p>
         </p:txBody>
@@ -7671,7 +7848,7 @@
               </a:defRPr>
             </a:pPr>
             <a:r>
-              <a:t>ME PROJECT  /  LOCALHOST DEMONSTRATION  /  EDITABLE PRESENTATION</a:t>
+              <a:t>SANTHIYA M  /  M.E. CSE, FINAL YEAR  /  SCAD COLLEGE OF ENGINEERING &amp; TECHNOLOGY</a:t>
             </a:r>
           </a:p>
         </p:txBody>
@@ -8146,7 +8323,7 @@
               </a:defRPr>
             </a:pPr>
             <a:r>
-              <a:t>ME PROJECT  /  LOCALHOST DEMONSTRATION  /  EDITABLE PRESENTATION</a:t>
+              <a:t>SANTHIYA M  /  M.E. CSE, FINAL YEAR  /  SCAD COLLEGE OF ENGINEERING &amp; TECHNOLOGY</a:t>
             </a:r>
           </a:p>
         </p:txBody>
@@ -8857,7 +9034,7 @@
               </a:defRPr>
             </a:pPr>
             <a:r>
-              <a:t>ME PROJECT  /  LOCALHOST DEMONSTRATION  /  EDITABLE PRESENTATION</a:t>
+              <a:t>SANTHIYA M  /  M.E. CSE, FINAL YEAR  /  SCAD COLLEGE OF ENGINEERING &amp; TECHNOLOGY</a:t>
             </a:r>
           </a:p>
         </p:txBody>
@@ -9293,7 +9470,7 @@
               </a:defRPr>
             </a:pPr>
             <a:r>
-              <a:t>ME PROJECT  /  LOCALHOST DEMONSTRATION  /  EDITABLE PRESENTATION</a:t>
+              <a:t>SANTHIYA M  /  M.E. CSE, FINAL YEAR  /  SCAD COLLEGE OF ENGINEERING &amp; TECHNOLOGY</a:t>
             </a:r>
           </a:p>
         </p:txBody>
@@ -9644,7 +9821,7 @@
               </a:defRPr>
             </a:pPr>
             <a:r>
-              <a:t>ME PROJECT  /  LOCALHOST DEMONSTRATION  /  EDITABLE PRESENTATION</a:t>
+              <a:t>SANTHIYA M  /  M.E. CSE, FINAL YEAR  /  SCAD COLLEGE OF ENGINEERING &amp; TECHNOLOGY</a:t>
             </a:r>
           </a:p>
         </p:txBody>
@@ -10080,7 +10257,7 @@
               </a:defRPr>
             </a:pPr>
             <a:r>
-              <a:t>ME PROJECT  /  LOCALHOST DEMONSTRATION  /  EDITABLE PRESENTATION</a:t>
+              <a:t>SANTHIYA M  /  M.E. CSE, FINAL YEAR  /  SCAD COLLEGE OF ENGINEERING &amp; TECHNOLOGY</a:t>
             </a:r>
           </a:p>
         </p:txBody>
@@ -11082,7 +11259,7 @@
               </a:defRPr>
             </a:pPr>
             <a:r>
-              <a:t>ME PROJECT  /  LOCALHOST DEMONSTRATION  /  EDITABLE PRESENTATION</a:t>
+              <a:t>SANTHIYA M  /  M.E. CSE, FINAL YEAR  /  SCAD COLLEGE OF ENGINEERING &amp; TECHNOLOGY</a:t>
             </a:r>
           </a:p>
         </p:txBody>
@@ -11927,7 +12104,7 @@
               </a:defRPr>
             </a:pPr>
             <a:r>
-              <a:t>ME PROJECT  /  LOCALHOST DEMONSTRATION  /  EDITABLE PRESENTATION</a:t>
+              <a:t>SANTHIYA M  /  M.E. CSE, FINAL YEAR  /  SCAD COLLEGE OF ENGINEERING &amp; TECHNOLOGY</a:t>
             </a:r>
           </a:p>
         </p:txBody>
@@ -12716,7 +12893,7 @@
               </a:defRPr>
             </a:pPr>
             <a:r>
-              <a:t>ME PROJECT  /  LOCALHOST DEMONSTRATION  /  EDITABLE PRESENTATION</a:t>
+              <a:t>SANTHIYA M  /  M.E. CSE, FINAL YEAR  /  SCAD COLLEGE OF ENGINEERING &amp; TECHNOLOGY</a:t>
             </a:r>
           </a:p>
         </p:txBody>
@@ -13484,7 +13661,7 @@
               </a:defRPr>
             </a:pPr>
             <a:r>
-              <a:t>ME PROJECT  /  LOCALHOST DEMONSTRATION  /  EDITABLE PRESENTATION</a:t>
+              <a:t>SANTHIYA M  /  M.E. CSE, FINAL YEAR  /  SCAD COLLEGE OF ENGINEERING &amp; TECHNOLOGY</a:t>
             </a:r>
           </a:p>
         </p:txBody>
@@ -14085,7 +14262,7 @@
               </a:defRPr>
             </a:pPr>
             <a:r>
-              <a:t>ME PROJECT  /  LOCALHOST DEMONSTRATION  /  EDITABLE PRESENTATION</a:t>
+              <a:t>SANTHIYA M  /  M.E. CSE, FINAL YEAR  /  SCAD COLLEGE OF ENGINEERING &amp; TECHNOLOGY</a:t>
             </a:r>
           </a:p>
         </p:txBody>
@@ -14700,7 +14877,7 @@
               </a:defRPr>
             </a:pPr>
             <a:r>
-              <a:t>ME PROJECT  /  LOCALHOST DEMONSTRATION  /  EDITABLE PRESENTATION</a:t>
+              <a:t>SANTHIYA M  /  M.E. CSE, FINAL YEAR  /  SCAD COLLEGE OF ENGINEERING &amp; TECHNOLOGY</a:t>
             </a:r>
           </a:p>
         </p:txBody>
@@ -15058,7 +15235,7 @@
               </a:defRPr>
             </a:pPr>
             <a:r>
-              <a:t>ME PROJECT  /  LOCALHOST DEMONSTRATION  /  EDITABLE PRESENTATION</a:t>
+              <a:t>SANTHIYA M  /  M.E. CSE, FINAL YEAR  /  SCAD COLLEGE OF ENGINEERING &amp; TECHNOLOGY</a:t>
             </a:r>
           </a:p>
         </p:txBody>
@@ -15732,7 +15909,7 @@
               </a:defRPr>
             </a:pPr>
             <a:r>
-              <a:t>ME PROJECT  /  LOCALHOST DEMONSTRATION  /  EDITABLE PRESENTATION</a:t>
+              <a:t>SANTHIYA M  /  M.E. CSE, FINAL YEAR  /  SCAD COLLEGE OF ENGINEERING &amp; TECHNOLOGY</a:t>
             </a:r>
           </a:p>
         </p:txBody>
@@ -16695,7 +16872,7 @@
               </a:defRPr>
             </a:pPr>
             <a:r>
-              <a:t>ME PROJECT  /  LOCALHOST DEMONSTRATION  /  EDITABLE PRESENTATION</a:t>
+              <a:t>SANTHIYA M  /  M.E. CSE, FINAL YEAR  /  SCAD COLLEGE OF ENGINEERING &amp; TECHNOLOGY</a:t>
             </a:r>
           </a:p>
         </p:txBody>
@@ -17430,7 +17607,7 @@
               </a:defRPr>
             </a:pPr>
             <a:r>
-              <a:t>ME PROJECT  /  LOCALHOST DEMONSTRATION  /  EDITABLE PRESENTATION</a:t>
+              <a:t>SANTHIYA M  /  M.E. CSE, FINAL YEAR  /  SCAD COLLEGE OF ENGINEERING &amp; TECHNOLOGY</a:t>
             </a:r>
           </a:p>
         </p:txBody>
@@ -18951,7 +19128,7 @@
               </a:defRPr>
             </a:pPr>
             <a:r>
-              <a:t>ME PROJECT  /  LOCALHOST DEMONSTRATION  /  EDITABLE PRESENTATION</a:t>
+              <a:t>SANTHIYA M  /  M.E. CSE, FINAL YEAR  /  SCAD COLLEGE OF ENGINEERING &amp; TECHNOLOGY</a:t>
             </a:r>
           </a:p>
         </p:txBody>
@@ -19929,7 +20106,7 @@
               </a:defRPr>
             </a:pPr>
             <a:r>
-              <a:t>ME PROJECT  /  LOCALHOST DEMONSTRATION  /  EDITABLE PRESENTATION</a:t>
+              <a:t>SANTHIYA M  /  M.E. CSE, FINAL YEAR  /  SCAD COLLEGE OF ENGINEERING &amp; TECHNOLOGY</a:t>
             </a:r>
           </a:p>
         </p:txBody>
@@ -21132,7 +21309,7 @@
               </a:defRPr>
             </a:pPr>
             <a:r>
-              <a:t>ME PROJECT  /  LOCALHOST DEMONSTRATION  /  EDITABLE PRESENTATION</a:t>
+              <a:t>SANTHIYA M  /  M.E. CSE, FINAL YEAR  /  SCAD COLLEGE OF ENGINEERING &amp; TECHNOLOGY</a:t>
             </a:r>
           </a:p>
         </p:txBody>

</xml_diff>